<commit_message>
atualiza documentação, pôster e checklist com as correções dos riscos
</commit_message>
<xml_diff>
--- a/docs/poster/Poster_Health_In_Sight.pptx
+++ b/docs/poster/Poster_Health_In_Sight.pptx
@@ -5,9 +5,9 @@
     <p:sldMasterId id="2147483648" r:id="rId1"/>
   </p:sldMasterIdLst>
   <p:sldIdLst>
-    <p:sldId id="256" r:id="rId7"/>
+    <p:sldId id="256" r:id="rId2"/>
   </p:sldIdLst>
-  <p:sldSz cx="28800000" cy="36000000" type="screen4x3"/>
+  <p:sldSz cx="28800425" cy="35999738"/>
   <p:notesSz cx="6858000" cy="9144000"/>
   <p:defaultTextStyle>
     <a:defPPr>
@@ -104,6 +104,22 @@
       </a:defRPr>
     </a:lvl9pPr>
   </p:defaultTextStyle>
+  <p:extLst>
+    <p:ext uri="{EFAFB233-063F-42B5-8137-9DF3F51BA10A}">
+      <p15:sldGuideLst xmlns:p15="http://schemas.microsoft.com/office/powerpoint/2012/main">
+        <p15:guide id="1" orient="horz" pos="2160">
+          <p15:clr>
+            <a:srgbClr val="A4A3A4"/>
+          </p15:clr>
+        </p15:guide>
+        <p15:guide id="2" pos="2880">
+          <p15:clr>
+            <a:srgbClr val="A4A3A4"/>
+          </p15:clr>
+        </p15:guide>
+      </p15:sldGuideLst>
+    </p:ext>
+  </p:extLst>
 </p:presentation>
 </file>
 
@@ -145,10 +161,9 @@
           <a:lstStyle/>
           <a:p>
             <a:r>
-              <a:rPr lang="en-US" smtClean="0"/>
+              <a:rPr lang="en-US"/>
               <a:t>Click to edit Master title style</a:t>
             </a:r>
-            <a:endParaRPr lang="en-US"/>
           </a:p>
         </p:txBody>
       </p:sp>
@@ -264,10 +279,9 @@
           </a:lstStyle>
           <a:p>
             <a:r>
-              <a:rPr lang="en-US" smtClean="0"/>
+              <a:rPr lang="en-US"/>
               <a:t>Click to edit Master subtitle style</a:t>
             </a:r>
-            <a:endParaRPr lang="en-US"/>
           </a:p>
         </p:txBody>
       </p:sp>
@@ -288,7 +302,7 @@
           <a:p>
             <a:fld id="{5BCAD085-E8A6-8845-BD4E-CB4CCA059FC4}" type="datetimeFigureOut">
               <a:rPr lang="en-US" smtClean="0"/>
-              <a:t>1/27/13</a:t>
+              <a:t>10/20/2026</a:t>
             </a:fld>
             <a:endParaRPr lang="en-US"/>
           </a:p>
@@ -330,7 +344,7 @@
           <a:p>
             <a:fld id="{C1FF6DA9-008F-8B48-92A6-B652298478BF}" type="slidenum">
               <a:rPr lang="en-US" smtClean="0"/>
-              <a:t>‹#›</a:t>
+              <a:t>‹nº›</a:t>
             </a:fld>
             <a:endParaRPr lang="en-US"/>
           </a:p>
@@ -382,10 +396,9 @@
           <a:lstStyle/>
           <a:p>
             <a:r>
-              <a:rPr lang="en-US" smtClean="0"/>
+              <a:rPr lang="en-US"/>
               <a:t>Click to edit Master title style</a:t>
             </a:r>
-            <a:endParaRPr lang="en-US"/>
           </a:p>
         </p:txBody>
       </p:sp>
@@ -406,38 +419,37 @@
           <a:p>
             <a:pPr lvl="0"/>
             <a:r>
-              <a:rPr lang="en-US" smtClean="0"/>
+              <a:rPr lang="en-US"/>
               <a:t>Click to edit Master text styles</a:t>
             </a:r>
           </a:p>
           <a:p>
             <a:pPr lvl="1"/>
             <a:r>
-              <a:rPr lang="en-US" smtClean="0"/>
+              <a:rPr lang="en-US"/>
               <a:t>Second level</a:t>
             </a:r>
           </a:p>
           <a:p>
             <a:pPr lvl="2"/>
             <a:r>
-              <a:rPr lang="en-US" smtClean="0"/>
+              <a:rPr lang="en-US"/>
               <a:t>Third level</a:t>
             </a:r>
           </a:p>
           <a:p>
             <a:pPr lvl="3"/>
             <a:r>
-              <a:rPr lang="en-US" smtClean="0"/>
+              <a:rPr lang="en-US"/>
               <a:t>Fourth level</a:t>
             </a:r>
           </a:p>
           <a:p>
             <a:pPr lvl="4"/>
             <a:r>
-              <a:rPr lang="en-US" smtClean="0"/>
+              <a:rPr lang="en-US"/>
               <a:t>Fifth level</a:t>
             </a:r>
-            <a:endParaRPr lang="en-US"/>
           </a:p>
         </p:txBody>
       </p:sp>
@@ -458,7 +470,7 @@
           <a:p>
             <a:fld id="{5BCAD085-E8A6-8845-BD4E-CB4CCA059FC4}" type="datetimeFigureOut">
               <a:rPr lang="en-US" smtClean="0"/>
-              <a:t>1/27/13</a:t>
+              <a:t>10/20/2026</a:t>
             </a:fld>
             <a:endParaRPr lang="en-US"/>
           </a:p>
@@ -500,7 +512,7 @@
           <a:p>
             <a:fld id="{C1FF6DA9-008F-8B48-92A6-B652298478BF}" type="slidenum">
               <a:rPr lang="en-US" smtClean="0"/>
-              <a:t>‹#›</a:t>
+              <a:t>‹nº›</a:t>
             </a:fld>
             <a:endParaRPr lang="en-US"/>
           </a:p>
@@ -557,10 +569,9 @@
           <a:lstStyle/>
           <a:p>
             <a:r>
-              <a:rPr lang="en-US" smtClean="0"/>
+              <a:rPr lang="en-US"/>
               <a:t>Click to edit Master title style</a:t>
             </a:r>
-            <a:endParaRPr lang="en-US"/>
           </a:p>
         </p:txBody>
       </p:sp>
@@ -586,38 +597,37 @@
           <a:p>
             <a:pPr lvl="0"/>
             <a:r>
-              <a:rPr lang="en-US" smtClean="0"/>
+              <a:rPr lang="en-US"/>
               <a:t>Click to edit Master text styles</a:t>
             </a:r>
           </a:p>
           <a:p>
             <a:pPr lvl="1"/>
             <a:r>
-              <a:rPr lang="en-US" smtClean="0"/>
+              <a:rPr lang="en-US"/>
               <a:t>Second level</a:t>
             </a:r>
           </a:p>
           <a:p>
             <a:pPr lvl="2"/>
             <a:r>
-              <a:rPr lang="en-US" smtClean="0"/>
+              <a:rPr lang="en-US"/>
               <a:t>Third level</a:t>
             </a:r>
           </a:p>
           <a:p>
             <a:pPr lvl="3"/>
             <a:r>
-              <a:rPr lang="en-US" smtClean="0"/>
+              <a:rPr lang="en-US"/>
               <a:t>Fourth level</a:t>
             </a:r>
           </a:p>
           <a:p>
             <a:pPr lvl="4"/>
             <a:r>
-              <a:rPr lang="en-US" smtClean="0"/>
+              <a:rPr lang="en-US"/>
               <a:t>Fifth level</a:t>
             </a:r>
-            <a:endParaRPr lang="en-US"/>
           </a:p>
         </p:txBody>
       </p:sp>
@@ -638,7 +648,7 @@
           <a:p>
             <a:fld id="{5BCAD085-E8A6-8845-BD4E-CB4CCA059FC4}" type="datetimeFigureOut">
               <a:rPr lang="en-US" smtClean="0"/>
-              <a:t>1/27/13</a:t>
+              <a:t>10/20/2026</a:t>
             </a:fld>
             <a:endParaRPr lang="en-US"/>
           </a:p>
@@ -680,7 +690,7 @@
           <a:p>
             <a:fld id="{C1FF6DA9-008F-8B48-92A6-B652298478BF}" type="slidenum">
               <a:rPr lang="en-US" smtClean="0"/>
-              <a:t>‹#›</a:t>
+              <a:t>‹nº›</a:t>
             </a:fld>
             <a:endParaRPr lang="en-US"/>
           </a:p>
@@ -732,10 +742,9 @@
           <a:lstStyle/>
           <a:p>
             <a:r>
-              <a:rPr lang="en-US" smtClean="0"/>
+              <a:rPr lang="en-US"/>
               <a:t>Click to edit Master title style</a:t>
             </a:r>
-            <a:endParaRPr lang="en-US"/>
           </a:p>
         </p:txBody>
       </p:sp>
@@ -756,38 +765,37 @@
           <a:p>
             <a:pPr lvl="0"/>
             <a:r>
-              <a:rPr lang="en-US" smtClean="0"/>
+              <a:rPr lang="en-US"/>
               <a:t>Click to edit Master text styles</a:t>
             </a:r>
           </a:p>
           <a:p>
             <a:pPr lvl="1"/>
             <a:r>
-              <a:rPr lang="en-US" smtClean="0"/>
+              <a:rPr lang="en-US"/>
               <a:t>Second level</a:t>
             </a:r>
           </a:p>
           <a:p>
             <a:pPr lvl="2"/>
             <a:r>
-              <a:rPr lang="en-US" smtClean="0"/>
+              <a:rPr lang="en-US"/>
               <a:t>Third level</a:t>
             </a:r>
           </a:p>
           <a:p>
             <a:pPr lvl="3"/>
             <a:r>
-              <a:rPr lang="en-US" smtClean="0"/>
+              <a:rPr lang="en-US"/>
               <a:t>Fourth level</a:t>
             </a:r>
           </a:p>
           <a:p>
             <a:pPr lvl="4"/>
             <a:r>
-              <a:rPr lang="en-US" smtClean="0"/>
+              <a:rPr lang="en-US"/>
               <a:t>Fifth level</a:t>
             </a:r>
-            <a:endParaRPr lang="en-US"/>
           </a:p>
         </p:txBody>
       </p:sp>
@@ -808,7 +816,7 @@
           <a:p>
             <a:fld id="{5BCAD085-E8A6-8845-BD4E-CB4CCA059FC4}" type="datetimeFigureOut">
               <a:rPr lang="en-US" smtClean="0"/>
-              <a:t>1/27/13</a:t>
+              <a:t>10/20/2026</a:t>
             </a:fld>
             <a:endParaRPr lang="en-US"/>
           </a:p>
@@ -850,7 +858,7 @@
           <a:p>
             <a:fld id="{C1FF6DA9-008F-8B48-92A6-B652298478BF}" type="slidenum">
               <a:rPr lang="en-US" smtClean="0"/>
-              <a:t>‹#›</a:t>
+              <a:t>‹nº›</a:t>
             </a:fld>
             <a:endParaRPr lang="en-US"/>
           </a:p>
@@ -911,10 +919,9 @@
           </a:lstStyle>
           <a:p>
             <a:r>
-              <a:rPr lang="en-US" smtClean="0"/>
+              <a:rPr lang="en-US"/>
               <a:t>Click to edit Master title style</a:t>
             </a:r>
-            <a:endParaRPr lang="en-US"/>
           </a:p>
         </p:txBody>
       </p:sp>
@@ -1031,7 +1038,7 @@
           <a:p>
             <a:pPr lvl="0"/>
             <a:r>
-              <a:rPr lang="en-US" smtClean="0"/>
+              <a:rPr lang="en-US"/>
               <a:t>Click to edit Master text styles</a:t>
             </a:r>
           </a:p>
@@ -1054,7 +1061,7 @@
           <a:p>
             <a:fld id="{5BCAD085-E8A6-8845-BD4E-CB4CCA059FC4}" type="datetimeFigureOut">
               <a:rPr lang="en-US" smtClean="0"/>
-              <a:t>1/27/13</a:t>
+              <a:t>10/20/2026</a:t>
             </a:fld>
             <a:endParaRPr lang="en-US"/>
           </a:p>
@@ -1096,7 +1103,7 @@
           <a:p>
             <a:fld id="{C1FF6DA9-008F-8B48-92A6-B652298478BF}" type="slidenum">
               <a:rPr lang="en-US" smtClean="0"/>
-              <a:t>‹#›</a:t>
+              <a:t>‹nº›</a:t>
             </a:fld>
             <a:endParaRPr lang="en-US"/>
           </a:p>
@@ -1148,10 +1155,9 @@
           <a:lstStyle/>
           <a:p>
             <a:r>
-              <a:rPr lang="en-US" smtClean="0"/>
+              <a:rPr lang="en-US"/>
               <a:t>Click to edit Master title style</a:t>
             </a:r>
-            <a:endParaRPr lang="en-US"/>
           </a:p>
         </p:txBody>
       </p:sp>
@@ -1205,38 +1211,37 @@
           <a:p>
             <a:pPr lvl="0"/>
             <a:r>
-              <a:rPr lang="en-US" smtClean="0"/>
+              <a:rPr lang="en-US"/>
               <a:t>Click to edit Master text styles</a:t>
             </a:r>
           </a:p>
           <a:p>
             <a:pPr lvl="1"/>
             <a:r>
-              <a:rPr lang="en-US" smtClean="0"/>
+              <a:rPr lang="en-US"/>
               <a:t>Second level</a:t>
             </a:r>
           </a:p>
           <a:p>
             <a:pPr lvl="2"/>
             <a:r>
-              <a:rPr lang="en-US" smtClean="0"/>
+              <a:rPr lang="en-US"/>
               <a:t>Third level</a:t>
             </a:r>
           </a:p>
           <a:p>
             <a:pPr lvl="3"/>
             <a:r>
-              <a:rPr lang="en-US" smtClean="0"/>
+              <a:rPr lang="en-US"/>
               <a:t>Fourth level</a:t>
             </a:r>
           </a:p>
           <a:p>
             <a:pPr lvl="4"/>
             <a:r>
-              <a:rPr lang="en-US" smtClean="0"/>
+              <a:rPr lang="en-US"/>
               <a:t>Fifth level</a:t>
             </a:r>
-            <a:endParaRPr lang="en-US"/>
           </a:p>
         </p:txBody>
       </p:sp>
@@ -1290,38 +1295,37 @@
           <a:p>
             <a:pPr lvl="0"/>
             <a:r>
-              <a:rPr lang="en-US" smtClean="0"/>
+              <a:rPr lang="en-US"/>
               <a:t>Click to edit Master text styles</a:t>
             </a:r>
           </a:p>
           <a:p>
             <a:pPr lvl="1"/>
             <a:r>
-              <a:rPr lang="en-US" smtClean="0"/>
+              <a:rPr lang="en-US"/>
               <a:t>Second level</a:t>
             </a:r>
           </a:p>
           <a:p>
             <a:pPr lvl="2"/>
             <a:r>
-              <a:rPr lang="en-US" smtClean="0"/>
+              <a:rPr lang="en-US"/>
               <a:t>Third level</a:t>
             </a:r>
           </a:p>
           <a:p>
             <a:pPr lvl="3"/>
             <a:r>
-              <a:rPr lang="en-US" smtClean="0"/>
+              <a:rPr lang="en-US"/>
               <a:t>Fourth level</a:t>
             </a:r>
           </a:p>
           <a:p>
             <a:pPr lvl="4"/>
             <a:r>
-              <a:rPr lang="en-US" smtClean="0"/>
+              <a:rPr lang="en-US"/>
               <a:t>Fifth level</a:t>
             </a:r>
-            <a:endParaRPr lang="en-US"/>
           </a:p>
         </p:txBody>
       </p:sp>
@@ -1342,7 +1346,7 @@
           <a:p>
             <a:fld id="{5BCAD085-E8A6-8845-BD4E-CB4CCA059FC4}" type="datetimeFigureOut">
               <a:rPr lang="en-US" smtClean="0"/>
-              <a:t>1/27/13</a:t>
+              <a:t>10/20/2026</a:t>
             </a:fld>
             <a:endParaRPr lang="en-US"/>
           </a:p>
@@ -1384,7 +1388,7 @@
           <a:p>
             <a:fld id="{C1FF6DA9-008F-8B48-92A6-B652298478BF}" type="slidenum">
               <a:rPr lang="en-US" smtClean="0"/>
-              <a:t>‹#›</a:t>
+              <a:t>‹nº›</a:t>
             </a:fld>
             <a:endParaRPr lang="en-US"/>
           </a:p>
@@ -1440,10 +1444,9 @@
           </a:lstStyle>
           <a:p>
             <a:r>
-              <a:rPr lang="en-US" smtClean="0"/>
+              <a:rPr lang="en-US"/>
               <a:t>Click to edit Master title style</a:t>
             </a:r>
-            <a:endParaRPr lang="en-US"/>
           </a:p>
         </p:txBody>
       </p:sp>
@@ -1506,7 +1509,7 @@
           <a:p>
             <a:pPr lvl="0"/>
             <a:r>
-              <a:rPr lang="en-US" smtClean="0"/>
+              <a:rPr lang="en-US"/>
               <a:t>Click to edit Master text styles</a:t>
             </a:r>
           </a:p>
@@ -1562,38 +1565,37 @@
           <a:p>
             <a:pPr lvl="0"/>
             <a:r>
-              <a:rPr lang="en-US" smtClean="0"/>
+              <a:rPr lang="en-US"/>
               <a:t>Click to edit Master text styles</a:t>
             </a:r>
           </a:p>
           <a:p>
             <a:pPr lvl="1"/>
             <a:r>
-              <a:rPr lang="en-US" smtClean="0"/>
+              <a:rPr lang="en-US"/>
               <a:t>Second level</a:t>
             </a:r>
           </a:p>
           <a:p>
             <a:pPr lvl="2"/>
             <a:r>
-              <a:rPr lang="en-US" smtClean="0"/>
+              <a:rPr lang="en-US"/>
               <a:t>Third level</a:t>
             </a:r>
           </a:p>
           <a:p>
             <a:pPr lvl="3"/>
             <a:r>
-              <a:rPr lang="en-US" smtClean="0"/>
+              <a:rPr lang="en-US"/>
               <a:t>Fourth level</a:t>
             </a:r>
           </a:p>
           <a:p>
             <a:pPr lvl="4"/>
             <a:r>
-              <a:rPr lang="en-US" smtClean="0"/>
+              <a:rPr lang="en-US"/>
               <a:t>Fifth level</a:t>
             </a:r>
-            <a:endParaRPr lang="en-US"/>
           </a:p>
         </p:txBody>
       </p:sp>
@@ -1656,7 +1658,7 @@
           <a:p>
             <a:pPr lvl="0"/>
             <a:r>
-              <a:rPr lang="en-US" smtClean="0"/>
+              <a:rPr lang="en-US"/>
               <a:t>Click to edit Master text styles</a:t>
             </a:r>
           </a:p>
@@ -1712,38 +1714,37 @@
           <a:p>
             <a:pPr lvl="0"/>
             <a:r>
-              <a:rPr lang="en-US" smtClean="0"/>
+              <a:rPr lang="en-US"/>
               <a:t>Click to edit Master text styles</a:t>
             </a:r>
           </a:p>
           <a:p>
             <a:pPr lvl="1"/>
             <a:r>
-              <a:rPr lang="en-US" smtClean="0"/>
+              <a:rPr lang="en-US"/>
               <a:t>Second level</a:t>
             </a:r>
           </a:p>
           <a:p>
             <a:pPr lvl="2"/>
             <a:r>
-              <a:rPr lang="en-US" smtClean="0"/>
+              <a:rPr lang="en-US"/>
               <a:t>Third level</a:t>
             </a:r>
           </a:p>
           <a:p>
             <a:pPr lvl="3"/>
             <a:r>
-              <a:rPr lang="en-US" smtClean="0"/>
+              <a:rPr lang="en-US"/>
               <a:t>Fourth level</a:t>
             </a:r>
           </a:p>
           <a:p>
             <a:pPr lvl="4"/>
             <a:r>
-              <a:rPr lang="en-US" smtClean="0"/>
+              <a:rPr lang="en-US"/>
               <a:t>Fifth level</a:t>
             </a:r>
-            <a:endParaRPr lang="en-US"/>
           </a:p>
         </p:txBody>
       </p:sp>
@@ -1764,7 +1765,7 @@
           <a:p>
             <a:fld id="{5BCAD085-E8A6-8845-BD4E-CB4CCA059FC4}" type="datetimeFigureOut">
               <a:rPr lang="en-US" smtClean="0"/>
-              <a:t>1/27/13</a:t>
+              <a:t>10/20/2026</a:t>
             </a:fld>
             <a:endParaRPr lang="en-US"/>
           </a:p>
@@ -1806,7 +1807,7 @@
           <a:p>
             <a:fld id="{C1FF6DA9-008F-8B48-92A6-B652298478BF}" type="slidenum">
               <a:rPr lang="en-US" smtClean="0"/>
-              <a:t>‹#›</a:t>
+              <a:t>‹nº›</a:t>
             </a:fld>
             <a:endParaRPr lang="en-US"/>
           </a:p>
@@ -1858,10 +1859,9 @@
           <a:lstStyle/>
           <a:p>
             <a:r>
-              <a:rPr lang="en-US" smtClean="0"/>
+              <a:rPr lang="en-US"/>
               <a:t>Click to edit Master title style</a:t>
             </a:r>
-            <a:endParaRPr lang="en-US"/>
           </a:p>
         </p:txBody>
       </p:sp>
@@ -1882,7 +1882,7 @@
           <a:p>
             <a:fld id="{5BCAD085-E8A6-8845-BD4E-CB4CCA059FC4}" type="datetimeFigureOut">
               <a:rPr lang="en-US" smtClean="0"/>
-              <a:t>1/27/13</a:t>
+              <a:t>10/20/2026</a:t>
             </a:fld>
             <a:endParaRPr lang="en-US"/>
           </a:p>
@@ -1924,7 +1924,7 @@
           <a:p>
             <a:fld id="{C1FF6DA9-008F-8B48-92A6-B652298478BF}" type="slidenum">
               <a:rPr lang="en-US" smtClean="0"/>
-              <a:t>‹#›</a:t>
+              <a:t>‹nº›</a:t>
             </a:fld>
             <a:endParaRPr lang="en-US"/>
           </a:p>
@@ -1977,7 +1977,7 @@
           <a:p>
             <a:fld id="{5BCAD085-E8A6-8845-BD4E-CB4CCA059FC4}" type="datetimeFigureOut">
               <a:rPr lang="en-US" smtClean="0"/>
-              <a:t>1/27/13</a:t>
+              <a:t>10/20/2026</a:t>
             </a:fld>
             <a:endParaRPr lang="en-US"/>
           </a:p>
@@ -2019,7 +2019,7 @@
           <a:p>
             <a:fld id="{C1FF6DA9-008F-8B48-92A6-B652298478BF}" type="slidenum">
               <a:rPr lang="en-US" smtClean="0"/>
-              <a:t>‹#›</a:t>
+              <a:t>‹nº›</a:t>
             </a:fld>
             <a:endParaRPr lang="en-US"/>
           </a:p>
@@ -2080,10 +2080,9 @@
           </a:lstStyle>
           <a:p>
             <a:r>
-              <a:rPr lang="en-US" smtClean="0"/>
+              <a:rPr lang="en-US"/>
               <a:t>Click to edit Master title style</a:t>
             </a:r>
-            <a:endParaRPr lang="en-US"/>
           </a:p>
         </p:txBody>
       </p:sp>
@@ -2137,38 +2136,37 @@
           <a:p>
             <a:pPr lvl="0"/>
             <a:r>
-              <a:rPr lang="en-US" smtClean="0"/>
+              <a:rPr lang="en-US"/>
               <a:t>Click to edit Master text styles</a:t>
             </a:r>
           </a:p>
           <a:p>
             <a:pPr lvl="1"/>
             <a:r>
-              <a:rPr lang="en-US" smtClean="0"/>
+              <a:rPr lang="en-US"/>
               <a:t>Second level</a:t>
             </a:r>
           </a:p>
           <a:p>
             <a:pPr lvl="2"/>
             <a:r>
-              <a:rPr lang="en-US" smtClean="0"/>
+              <a:rPr lang="en-US"/>
               <a:t>Third level</a:t>
             </a:r>
           </a:p>
           <a:p>
             <a:pPr lvl="3"/>
             <a:r>
-              <a:rPr lang="en-US" smtClean="0"/>
+              <a:rPr lang="en-US"/>
               <a:t>Fourth level</a:t>
             </a:r>
           </a:p>
           <a:p>
             <a:pPr lvl="4"/>
             <a:r>
-              <a:rPr lang="en-US" smtClean="0"/>
+              <a:rPr lang="en-US"/>
               <a:t>Fifth level</a:t>
             </a:r>
-            <a:endParaRPr lang="en-US"/>
           </a:p>
         </p:txBody>
       </p:sp>
@@ -2231,7 +2229,7 @@
           <a:p>
             <a:pPr lvl="0"/>
             <a:r>
-              <a:rPr lang="en-US" smtClean="0"/>
+              <a:rPr lang="en-US"/>
               <a:t>Click to edit Master text styles</a:t>
             </a:r>
           </a:p>
@@ -2254,7 +2252,7 @@
           <a:p>
             <a:fld id="{5BCAD085-E8A6-8845-BD4E-CB4CCA059FC4}" type="datetimeFigureOut">
               <a:rPr lang="en-US" smtClean="0"/>
-              <a:t>1/27/13</a:t>
+              <a:t>10/20/2026</a:t>
             </a:fld>
             <a:endParaRPr lang="en-US"/>
           </a:p>
@@ -2296,7 +2294,7 @@
           <a:p>
             <a:fld id="{C1FF6DA9-008F-8B48-92A6-B652298478BF}" type="slidenum">
               <a:rPr lang="en-US" smtClean="0"/>
-              <a:t>‹#›</a:t>
+              <a:t>‹nº›</a:t>
             </a:fld>
             <a:endParaRPr lang="en-US"/>
           </a:p>
@@ -2357,10 +2355,9 @@
           </a:lstStyle>
           <a:p>
             <a:r>
-              <a:rPr lang="en-US" smtClean="0"/>
+              <a:rPr lang="en-US"/>
               <a:t>Click to edit Master title style</a:t>
             </a:r>
-            <a:endParaRPr lang="en-US"/>
           </a:p>
         </p:txBody>
       </p:sp>
@@ -2484,7 +2481,7 @@
           <a:p>
             <a:pPr lvl="0"/>
             <a:r>
-              <a:rPr lang="en-US" smtClean="0"/>
+              <a:rPr lang="en-US"/>
               <a:t>Click to edit Master text styles</a:t>
             </a:r>
           </a:p>
@@ -2507,7 +2504,7 @@
           <a:p>
             <a:fld id="{5BCAD085-E8A6-8845-BD4E-CB4CCA059FC4}" type="datetimeFigureOut">
               <a:rPr lang="en-US" smtClean="0"/>
-              <a:t>1/27/13</a:t>
+              <a:t>10/20/2026</a:t>
             </a:fld>
             <a:endParaRPr lang="en-US"/>
           </a:p>
@@ -2549,7 +2546,7 @@
           <a:p>
             <a:fld id="{C1FF6DA9-008F-8B48-92A6-B652298478BF}" type="slidenum">
               <a:rPr lang="en-US" smtClean="0"/>
-              <a:t>‹#›</a:t>
+              <a:t>‹nº›</a:t>
             </a:fld>
             <a:endParaRPr lang="en-US"/>
           </a:p>
@@ -2616,10 +2613,9 @@
           <a:lstStyle/>
           <a:p>
             <a:r>
-              <a:rPr lang="en-US" smtClean="0"/>
+              <a:rPr lang="en-US"/>
               <a:t>Click to edit Master title style</a:t>
             </a:r>
-            <a:endParaRPr lang="en-US"/>
           </a:p>
         </p:txBody>
       </p:sp>
@@ -2650,38 +2646,37 @@
           <a:p>
             <a:pPr lvl="0"/>
             <a:r>
-              <a:rPr lang="en-US" smtClean="0"/>
+              <a:rPr lang="en-US"/>
               <a:t>Click to edit Master text styles</a:t>
             </a:r>
           </a:p>
           <a:p>
             <a:pPr lvl="1"/>
             <a:r>
-              <a:rPr lang="en-US" smtClean="0"/>
+              <a:rPr lang="en-US"/>
               <a:t>Second level</a:t>
             </a:r>
           </a:p>
           <a:p>
             <a:pPr lvl="2"/>
             <a:r>
-              <a:rPr lang="en-US" smtClean="0"/>
+              <a:rPr lang="en-US"/>
               <a:t>Third level</a:t>
             </a:r>
           </a:p>
           <a:p>
             <a:pPr lvl="3"/>
             <a:r>
-              <a:rPr lang="en-US" smtClean="0"/>
+              <a:rPr lang="en-US"/>
               <a:t>Fourth level</a:t>
             </a:r>
           </a:p>
           <a:p>
             <a:pPr lvl="4"/>
             <a:r>
-              <a:rPr lang="en-US" smtClean="0"/>
+              <a:rPr lang="en-US"/>
               <a:t>Fifth level</a:t>
             </a:r>
-            <a:endParaRPr lang="en-US"/>
           </a:p>
         </p:txBody>
       </p:sp>
@@ -2720,7 +2715,7 @@
           <a:p>
             <a:fld id="{5BCAD085-E8A6-8845-BD4E-CB4CCA059FC4}" type="datetimeFigureOut">
               <a:rPr lang="en-US" smtClean="0"/>
-              <a:t>1/27/13</a:t>
+              <a:t>10/20/2026</a:t>
             </a:fld>
             <a:endParaRPr lang="en-US"/>
           </a:p>
@@ -2798,7 +2793,7 @@
           <a:p>
             <a:fld id="{C1FF6DA9-008F-8B48-92A6-B652298478BF}" type="slidenum">
               <a:rPr lang="en-US" smtClean="0"/>
-              <a:t>‹#›</a:t>
+              <a:t>‹nº›</a:t>
             </a:fld>
             <a:endParaRPr lang="en-US"/>
           </a:p>
@@ -3079,7 +3074,7 @@
 </file>
 
 <file path=ppt/slides/slide1.xml><?xml version="1.0" encoding="utf-8"?>
-<p:sld xmlns:a="http://schemas.openxmlformats.org/drawingml/2006/main" xmlns:p="http://schemas.openxmlformats.org/presentationml/2006/main" xmlns:r="http://schemas.openxmlformats.org/officeDocument/2006/relationships">
+<p:sld xmlns:a="http://schemas.openxmlformats.org/drawingml/2006/main" xmlns:r="http://schemas.openxmlformats.org/officeDocument/2006/relationships" xmlns:p="http://schemas.openxmlformats.org/presentationml/2006/main">
   <p:cSld>
     <p:spTree>
       <p:nvGrpSpPr>
@@ -3087,7 +3082,14 @@
         <p:cNvGrpSpPr/>
         <p:nvPr/>
       </p:nvGrpSpPr>
-      <p:grpSpPr/>
+      <p:grpSpPr>
+        <a:xfrm>
+          <a:off x="0" y="0"/>
+          <a:ext cx="0" cy="0"/>
+          <a:chOff x="0" y="0"/>
+          <a:chExt cx="0" cy="0"/>
+        </a:xfrm>
+      </p:grpSpPr>
       <p:pic>
         <p:nvPicPr>
           <p:cNvPr id="2" name="Picture 1" descr="fundo-1.jpg"/>
@@ -3129,7 +3131,7 @@
           <a:noFill/>
         </p:spPr>
         <p:txBody>
-          <a:bodyPr wrap="square" anchor="ctr" lIns="43200" rIns="43200" tIns="43200" bIns="43200"/>
+          <a:bodyPr wrap="square" lIns="43200" tIns="43200" rIns="43200" bIns="43200" anchor="ctr"/>
           <a:lstStyle/>
           <a:p>
             <a:pPr algn="l">
@@ -3169,7 +3171,7 @@
           <a:noFill/>
         </p:spPr>
         <p:txBody>
-          <a:bodyPr wrap="square" anchor="t" lIns="43200" rIns="43200" tIns="43200" bIns="43200"/>
+          <a:bodyPr wrap="square" lIns="43200" tIns="43200" rIns="43200" bIns="43200" anchor="t"/>
           <a:lstStyle/>
           <a:p>
             <a:pPr algn="l">
@@ -3271,7 +3273,7 @@
           <a:noFill/>
         </p:spPr>
         <p:txBody>
-          <a:bodyPr wrap="square" anchor="t" lIns="43200" rIns="43200" tIns="43200" bIns="43200"/>
+          <a:bodyPr wrap="square" lIns="43200" tIns="43200" rIns="43200" bIns="43200" anchor="t"/>
           <a:lstStyle/>
           <a:p>
             <a:pPr algn="ctr">
@@ -3333,7 +3335,7 @@
           </a:fontRef>
         </p:style>
         <p:txBody>
-          <a:bodyPr rtlCol="0" anchor="ctr" wrap="square" lIns="108000" rIns="108000" tIns="54000" bIns="54000"/>
+          <a:bodyPr wrap="square" lIns="108000" tIns="54000" rIns="108000" bIns="54000" rtlCol="0" anchor="ctr"/>
           <a:lstStyle/>
           <a:p>
             <a:pPr algn="ctr">
@@ -3370,7 +3372,7 @@
           <a:noFill/>
         </p:spPr>
         <p:txBody>
-          <a:bodyPr wrap="square" anchor="t" lIns="43200" rIns="43200" tIns="43200" bIns="43200"/>
+          <a:bodyPr wrap="square" lIns="43200" tIns="43200" rIns="43200" bIns="43200" anchor="t"/>
           <a:lstStyle/>
           <a:p>
             <a:pPr algn="l">
@@ -3432,7 +3434,7 @@
           </a:fontRef>
         </p:style>
         <p:txBody>
-          <a:bodyPr rtlCol="0" anchor="ctr" wrap="square" lIns="108000" rIns="108000" tIns="54000" bIns="54000"/>
+          <a:bodyPr wrap="square" lIns="108000" tIns="54000" rIns="108000" bIns="54000" rtlCol="0" anchor="ctr"/>
           <a:lstStyle/>
           <a:p>
             <a:pPr algn="ctr">
@@ -3469,7 +3471,7 @@
           <a:noFill/>
         </p:spPr>
         <p:txBody>
-          <a:bodyPr wrap="square" anchor="t" lIns="43200" rIns="43200" tIns="43200" bIns="43200"/>
+          <a:bodyPr wrap="square" lIns="43200" tIns="43200" rIns="43200" bIns="43200" anchor="t"/>
           <a:lstStyle/>
           <a:p>
             <a:pPr algn="l">
@@ -3531,7 +3533,7 @@
           </a:fontRef>
         </p:style>
         <p:txBody>
-          <a:bodyPr rtlCol="0" anchor="ctr" wrap="square" lIns="108000" rIns="108000" tIns="54000" bIns="54000"/>
+          <a:bodyPr wrap="square" lIns="108000" tIns="54000" rIns="108000" bIns="54000" rtlCol="0" anchor="ctr"/>
           <a:lstStyle/>
           <a:p>
             <a:pPr algn="ctr">
@@ -3568,7 +3570,7 @@
           <a:noFill/>
         </p:spPr>
         <p:txBody>
-          <a:bodyPr wrap="square" anchor="t" lIns="43200" rIns="43200" tIns="43200" bIns="43200"/>
+          <a:bodyPr wrap="square" lIns="43200" tIns="43200" rIns="43200" bIns="43200" anchor="t"/>
           <a:lstStyle/>
           <a:p>
             <a:pPr algn="l">
@@ -3707,7 +3709,25 @@
                 </a:solidFill>
                 <a:latin typeface="Arial"/>
               </a:rPr>
-              <a:t>Testamos com 92 testes automatizados e varreduras de segurança a cada commit.</a:t>
+              <a:t>Testamos com </a:t>
+            </a:r>
+            <a:r>
+              <a:rPr lang="pt-BR" sz="2200" b="0">
+                <a:solidFill>
+                  <a:srgbClr val="262038"/>
+                </a:solidFill>
+                <a:latin typeface="Arial"/>
+              </a:rPr>
+              <a:t>146 testes automatizados</a:t>
+            </a:r>
+            <a:r>
+              <a:rPr sz="2200" b="0">
+                <a:solidFill>
+                  <a:srgbClr val="262038"/>
+                </a:solidFill>
+                <a:latin typeface="Arial"/>
+              </a:rPr>
+              <a:t> e varreduras de segurança a cada commit.</a:t>
             </a:r>
           </a:p>
         </p:txBody>
@@ -3751,7 +3771,7 @@
           </a:fontRef>
         </p:style>
         <p:txBody>
-          <a:bodyPr rtlCol="0" anchor="ctr" wrap="square" lIns="108000" rIns="108000" tIns="54000" bIns="54000"/>
+          <a:bodyPr wrap="square" lIns="108000" tIns="54000" rIns="108000" bIns="54000" rtlCol="0" anchor="ctr"/>
           <a:lstStyle/>
           <a:p>
             <a:pPr algn="ctr">
@@ -3812,7 +3832,7 @@
           </a:fontRef>
         </p:style>
         <p:txBody>
-          <a:bodyPr rtlCol="0" anchor="ctr" wrap="square" lIns="108000" rIns="108000" tIns="54000" bIns="54000"/>
+          <a:bodyPr wrap="square" lIns="108000" tIns="54000" rIns="108000" bIns="54000" rtlCol="0" anchor="ctr"/>
           <a:lstStyle/>
           <a:p>
             <a:pPr algn="ctr">
@@ -3889,7 +3909,7 @@
           </a:fontRef>
         </p:style>
         <p:txBody>
-          <a:bodyPr rtlCol="0" anchor="ctr" wrap="square" lIns="108000" rIns="108000" tIns="54000" bIns="54000"/>
+          <a:bodyPr wrap="square" lIns="108000" tIns="54000" rIns="108000" bIns="54000" rtlCol="0" anchor="ctr"/>
           <a:lstStyle/>
           <a:p>
             <a:pPr algn="ctr">
@@ -4002,7 +4022,7 @@
           </a:fontRef>
         </p:style>
         <p:txBody>
-          <a:bodyPr rtlCol="0" anchor="ctr" wrap="square" lIns="108000" rIns="108000" tIns="54000" bIns="54000"/>
+          <a:bodyPr wrap="square" lIns="108000" tIns="54000" rIns="108000" bIns="54000" rtlCol="0" anchor="ctr"/>
           <a:lstStyle/>
           <a:p>
             <a:pPr algn="ctr">
@@ -4115,7 +4135,7 @@
           </a:fontRef>
         </p:style>
         <p:txBody>
-          <a:bodyPr rtlCol="0" anchor="ctr" wrap="square" lIns="108000" rIns="108000" tIns="54000" bIns="54000"/>
+          <a:bodyPr wrap="square" lIns="108000" tIns="54000" rIns="108000" bIns="54000" rtlCol="0" anchor="ctr"/>
           <a:lstStyle/>
           <a:p>
             <a:pPr algn="ctr">
@@ -4228,7 +4248,7 @@
           </a:fontRef>
         </p:style>
         <p:txBody>
-          <a:bodyPr rtlCol="0" anchor="ctr" wrap="square" lIns="108000" rIns="108000" tIns="54000" bIns="54000"/>
+          <a:bodyPr wrap="square" lIns="108000" tIns="54000" rIns="108000" bIns="54000" rtlCol="0" anchor="ctr"/>
           <a:lstStyle/>
           <a:p>
             <a:pPr algn="ctr">
@@ -4253,14 +4273,20 @@
               </a:lnSpc>
             </a:pPr>
             <a:r>
-              <a:rPr sz="1700" b="0">
+              <a:rPr lang="pt-BR" sz="1700" b="0">
                 <a:solidFill>
                   <a:srgbClr val="262038"/>
                 </a:solidFill>
                 <a:latin typeface="Arial"/>
               </a:rPr>
-              <a:t>conta bloqueada por 5 min</a:t>
-            </a:r>
+              <a:t>bloqueio de 5 min, que dobra</a:t>
+            </a:r>
+            <a:endParaRPr sz="1700" b="0">
+              <a:solidFill>
+                <a:srgbClr val="262038"/>
+              </a:solidFill>
+              <a:latin typeface="Arial"/>
+            </a:endParaRPr>
           </a:p>
         </p:txBody>
       </p:sp>
@@ -4339,7 +4365,7 @@
           </a:fontRef>
         </p:style>
         <p:txBody>
-          <a:bodyPr rtlCol="0" anchor="ctr" wrap="square" lIns="108000" rIns="108000" tIns="54000" bIns="54000"/>
+          <a:bodyPr wrap="square" lIns="108000" tIns="54000" rIns="108000" bIns="54000" rtlCol="0" anchor="ctr"/>
           <a:lstStyle/>
           <a:p>
             <a:pPr algn="ctr">
@@ -4434,7 +4460,7 @@
           </a:fontRef>
         </p:style>
         <p:txBody>
-          <a:bodyPr rtlCol="0" anchor="ctr" wrap="square" lIns="108000" rIns="108000" tIns="54000" bIns="54000"/>
+          <a:bodyPr wrap="square" lIns="108000" tIns="54000" rIns="108000" bIns="54000" rtlCol="0" anchor="ctr"/>
           <a:lstStyle/>
           <a:p>
             <a:pPr algn="ctr">
@@ -4495,7 +4521,7 @@
           </a:fontRef>
         </p:style>
         <p:txBody>
-          <a:bodyPr rtlCol="0" anchor="ctr" wrap="square" lIns="108000" rIns="108000" tIns="54000" bIns="54000"/>
+          <a:bodyPr wrap="square" lIns="108000" tIns="54000" rIns="108000" bIns="54000" rtlCol="0" anchor="ctr"/>
           <a:lstStyle/>
           <a:p>
             <a:pPr algn="ctr">
@@ -4572,10 +4598,11 @@
           </a:fontRef>
         </p:style>
         <p:txBody>
-          <a:bodyPr rtlCol="0" anchor="ctr" wrap="square" lIns="108000" rIns="108000" tIns="54000" bIns="54000"/>
+          <a:bodyPr wrap="square" lIns="108000" tIns="54000" rIns="108000" bIns="54000" rtlCol="0" anchor="ctr"/>
           <a:lstStyle/>
           <a:p>
             <a:pPr algn="ctr"/>
+            <a:endParaRPr/>
           </a:p>
         </p:txBody>
       </p:sp>
@@ -4596,7 +4623,7 @@
           <a:noFill/>
         </p:spPr>
         <p:txBody>
-          <a:bodyPr wrap="square" anchor="t" lIns="43200" rIns="43200" tIns="43200" bIns="43200"/>
+          <a:bodyPr wrap="square" lIns="43200" tIns="43200" rIns="43200" bIns="43200" anchor="t"/>
           <a:lstStyle/>
           <a:p>
             <a:pPr algn="ctr">
@@ -4660,7 +4687,7 @@
           </a:fontRef>
         </p:style>
         <p:txBody>
-          <a:bodyPr rtlCol="0" anchor="ctr" wrap="square" lIns="108000" rIns="108000" tIns="54000" bIns="54000"/>
+          <a:bodyPr wrap="square" lIns="108000" tIns="54000" rIns="108000" bIns="54000" rtlCol="0" anchor="ctr"/>
           <a:lstStyle/>
           <a:p>
             <a:pPr algn="ctr">
@@ -4730,7 +4757,7 @@
           </a:fontRef>
         </p:style>
         <p:txBody>
-          <a:bodyPr rtlCol="0" anchor="ctr" wrap="square" lIns="108000" rIns="108000" tIns="54000" bIns="54000"/>
+          <a:bodyPr wrap="square" lIns="108000" tIns="54000" rIns="108000" bIns="54000" rtlCol="0" anchor="ctr"/>
           <a:lstStyle/>
           <a:p>
             <a:pPr algn="ctr">
@@ -4800,7 +4827,7 @@
           </a:fontRef>
         </p:style>
         <p:txBody>
-          <a:bodyPr rtlCol="0" anchor="ctr" wrap="square" lIns="108000" rIns="108000" tIns="54000" bIns="54000"/>
+          <a:bodyPr wrap="square" lIns="108000" tIns="54000" rIns="108000" bIns="54000" rtlCol="0" anchor="ctr"/>
           <a:lstStyle/>
           <a:p>
             <a:pPr algn="ctr">
@@ -4870,7 +4897,7 @@
           </a:fontRef>
         </p:style>
         <p:txBody>
-          <a:bodyPr rtlCol="0" anchor="ctr" wrap="square" lIns="108000" rIns="108000" tIns="54000" bIns="54000"/>
+          <a:bodyPr wrap="square" lIns="108000" tIns="54000" rIns="108000" bIns="54000" rtlCol="0" anchor="ctr"/>
           <a:lstStyle/>
           <a:p>
             <a:pPr algn="ctr">
@@ -4940,7 +4967,7 @@
           </a:fontRef>
         </p:style>
         <p:txBody>
-          <a:bodyPr rtlCol="0" anchor="ctr" wrap="square" lIns="108000" rIns="108000" tIns="54000" bIns="54000"/>
+          <a:bodyPr wrap="square" lIns="108000" tIns="54000" rIns="108000" bIns="54000" rtlCol="0" anchor="ctr"/>
           <a:lstStyle/>
           <a:p>
             <a:pPr algn="ctr">
@@ -5010,7 +5037,7 @@
           </a:fontRef>
         </p:style>
         <p:txBody>
-          <a:bodyPr rtlCol="0" anchor="ctr" wrap="square" lIns="108000" rIns="108000" tIns="54000" bIns="54000"/>
+          <a:bodyPr wrap="square" lIns="108000" tIns="54000" rIns="108000" bIns="54000" rtlCol="0" anchor="ctr"/>
           <a:lstStyle/>
           <a:p>
             <a:pPr algn="ctr">
@@ -5099,7 +5126,7 @@
           <a:noFill/>
         </p:spPr>
         <p:txBody>
-          <a:bodyPr wrap="square" anchor="b" lIns="43200" rIns="43200" tIns="43200" bIns="43200"/>
+          <a:bodyPr wrap="square" lIns="43200" tIns="43200" rIns="43200" bIns="43200" anchor="b"/>
           <a:lstStyle/>
           <a:p>
             <a:pPr algn="ctr">
@@ -5194,7 +5221,7 @@
           <a:noFill/>
         </p:spPr>
         <p:txBody>
-          <a:bodyPr wrap="square" anchor="b" lIns="43200" rIns="43200" tIns="43200" bIns="43200"/>
+          <a:bodyPr wrap="square" lIns="43200" tIns="43200" rIns="43200" bIns="43200" anchor="b"/>
           <a:lstStyle/>
           <a:p>
             <a:pPr algn="ctr">
@@ -5277,7 +5304,7 @@
           </a:fontRef>
         </p:style>
         <p:txBody>
-          <a:bodyPr rtlCol="0" anchor="ctr" wrap="square" lIns="108000" rIns="108000" tIns="54000" bIns="54000"/>
+          <a:bodyPr wrap="square" lIns="108000" tIns="54000" rIns="108000" bIns="54000" rtlCol="0" anchor="ctr"/>
           <a:lstStyle/>
           <a:p>
             <a:pPr algn="ctr">
@@ -5390,7 +5417,7 @@
           </a:fontRef>
         </p:style>
         <p:txBody>
-          <a:bodyPr rtlCol="0" anchor="ctr" wrap="square" lIns="108000" rIns="108000" tIns="54000" bIns="54000"/>
+          <a:bodyPr wrap="square" lIns="108000" tIns="54000" rIns="108000" bIns="54000" rtlCol="0" anchor="ctr"/>
           <a:lstStyle/>
           <a:p>
             <a:pPr algn="ctr">
@@ -5501,7 +5528,7 @@
           </a:fontRef>
         </p:style>
         <p:txBody>
-          <a:bodyPr rtlCol="0" anchor="ctr" wrap="square" lIns="108000" rIns="108000" tIns="54000" bIns="54000"/>
+          <a:bodyPr wrap="square" lIns="108000" tIns="54000" rIns="108000" bIns="54000" rtlCol="0" anchor="ctr"/>
           <a:lstStyle/>
           <a:p>
             <a:pPr algn="ctr">
@@ -5562,7 +5589,7 @@
           </a:fontRef>
         </p:style>
         <p:txBody>
-          <a:bodyPr rtlCol="0" anchor="ctr" wrap="square" lIns="108000" rIns="108000" tIns="54000" bIns="54000"/>
+          <a:bodyPr wrap="square" lIns="108000" tIns="54000" rIns="108000" bIns="54000" rtlCol="0" anchor="ctr"/>
           <a:lstStyle/>
           <a:p>
             <a:pPr algn="ctr">
@@ -5639,7 +5666,7 @@
           </a:fontRef>
         </p:style>
         <p:txBody>
-          <a:bodyPr rtlCol="0" anchor="ctr" wrap="square" lIns="108000" rIns="108000" tIns="54000" bIns="54000"/>
+          <a:bodyPr wrap="square" lIns="108000" tIns="54000" rIns="108000" bIns="54000" rtlCol="0" anchor="ctr"/>
           <a:lstStyle/>
           <a:p>
             <a:pPr algn="ctr">
@@ -5750,7 +5777,7 @@
           </a:fontRef>
         </p:style>
         <p:txBody>
-          <a:bodyPr rtlCol="0" anchor="ctr" wrap="square" lIns="108000" rIns="108000" tIns="54000" bIns="54000"/>
+          <a:bodyPr wrap="square" lIns="108000" tIns="54000" rIns="108000" bIns="54000" rtlCol="0" anchor="ctr"/>
           <a:lstStyle/>
           <a:p>
             <a:pPr algn="ctr">
@@ -5811,7 +5838,7 @@
           </a:fontRef>
         </p:style>
         <p:txBody>
-          <a:bodyPr rtlCol="0" anchor="ctr" wrap="square" lIns="108000" rIns="108000" tIns="54000" bIns="54000"/>
+          <a:bodyPr wrap="square" lIns="108000" tIns="54000" rIns="108000" bIns="54000" rtlCol="0" anchor="ctr"/>
           <a:lstStyle/>
           <a:p>
             <a:pPr algn="ctr">
@@ -5945,7 +5972,7 @@
           <a:noFill/>
         </p:spPr>
         <p:txBody>
-          <a:bodyPr wrap="square" anchor="t" lIns="43200" rIns="43200" tIns="43200" bIns="43200"/>
+          <a:bodyPr wrap="square" lIns="43200" tIns="43200" rIns="43200" bIns="43200" anchor="t"/>
           <a:lstStyle/>
           <a:p>
             <a:pPr algn="l">
@@ -6007,7 +6034,7 @@
           </a:fontRef>
         </p:style>
         <p:txBody>
-          <a:bodyPr rtlCol="0" anchor="ctr" wrap="square" lIns="108000" rIns="108000" tIns="54000" bIns="54000"/>
+          <a:bodyPr wrap="square" lIns="108000" tIns="54000" rIns="108000" bIns="54000" rtlCol="0" anchor="ctr"/>
           <a:lstStyle/>
           <a:p>
             <a:pPr algn="ctr">
@@ -6033,7 +6060,13 @@
           <p:cNvGraphicFramePr>
             <a:graphicFrameLocks noGrp="1"/>
           </p:cNvGraphicFramePr>
-          <p:nvPr/>
+          <p:nvPr>
+            <p:extLst>
+              <p:ext uri="{D42A27DB-BD31-4B8C-83A1-F6EECF244321}">
+                <p14:modId xmlns:p14="http://schemas.microsoft.com/office/powerpoint/2010/main" val="1076320986"/>
+              </p:ext>
+            </p:extLst>
+          </p:nvPr>
         </p:nvGraphicFramePr>
         <p:xfrm>
           <a:off x="10018800" y="21402000"/>
@@ -6046,8 +6079,20 @@
                 <a:tableStyleId>{5C22544A-7EE6-4342-B048-85BDC9FD1C3A}</a:tableStyleId>
               </a:tblPr>
               <a:tblGrid>
-                <a:gridCol w="2160000"/>
-                <a:gridCol w="6598799"/>
+                <a:gridCol w="2160000">
+                  <a:extLst>
+                    <a:ext uri="{9D8B030D-6E8A-4147-A177-3AD203B41FA5}">
+                      <a16:colId xmlns:a16="http://schemas.microsoft.com/office/drawing/2014/main" val="20000"/>
+                    </a:ext>
+                  </a:extLst>
+                </a:gridCol>
+                <a:gridCol w="6598799">
+                  <a:extLst>
+                    <a:ext uri="{9D8B030D-6E8A-4147-A177-3AD203B41FA5}">
+                      <a16:colId xmlns:a16="http://schemas.microsoft.com/office/drawing/2014/main" val="20001"/>
+                    </a:ext>
+                  </a:extLst>
+                </a:gridCol>
               </a:tblGrid>
               <a:tr h="360000">
                 <a:tc>
@@ -6094,6 +6139,11 @@
                     </a:solidFill>
                   </a:tcPr>
                 </a:tc>
+                <a:extLst>
+                  <a:ext uri="{0D108BD9-81ED-4DB2-BD59-A6C34878D82A}">
+                    <a16:rowId xmlns:a16="http://schemas.microsoft.com/office/drawing/2014/main" val="10000"/>
+                  </a:ext>
+                </a:extLst>
               </a:tr>
               <a:tr h="558000">
                 <a:tc>
@@ -6140,6 +6190,11 @@
                     </a:solidFill>
                   </a:tcPr>
                 </a:tc>
+                <a:extLst>
+                  <a:ext uri="{0D108BD9-81ED-4DB2-BD59-A6C34878D82A}">
+                    <a16:rowId xmlns:a16="http://schemas.microsoft.com/office/drawing/2014/main" val="10001"/>
+                  </a:ext>
+                </a:extLst>
               </a:tr>
               <a:tr h="558000">
                 <a:tc>
@@ -6186,6 +6241,11 @@
                     </a:solidFill>
                   </a:tcPr>
                 </a:tc>
+                <a:extLst>
+                  <a:ext uri="{0D108BD9-81ED-4DB2-BD59-A6C34878D82A}">
+                    <a16:rowId xmlns:a16="http://schemas.microsoft.com/office/drawing/2014/main" val="10002"/>
+                  </a:ext>
+                </a:extLst>
               </a:tr>
               <a:tr h="558000">
                 <a:tc>
@@ -6222,8 +6282,23 @@
                           </a:solidFill>
                           <a:latin typeface="Arial"/>
                         </a:rPr>
-                        <a:t>sessão de 15 min; 5 senhas erradas bloqueiam a conta por 5 min</a:t>
+                        <a:t>sessão de 15 min; </a:t>
                       </a:r>
+                      <a:r>
+                        <a:rPr lang="pt-BR" sz="1800" b="0">
+                          <a:solidFill>
+                            <a:srgbClr val="262038"/>
+                          </a:solidFill>
+                          <a:latin typeface="Arial"/>
+                        </a:rPr>
+                        <a:t>5 senhas erradas bloqueiam a conta por 5 min, o dobro se repetir</a:t>
+                      </a:r>
+                      <a:endParaRPr sz="1800" b="0">
+                        <a:solidFill>
+                          <a:srgbClr val="262038"/>
+                        </a:solidFill>
+                        <a:latin typeface="Arial"/>
+                      </a:endParaRPr>
                     </a:p>
                   </a:txBody>
                   <a:tcPr marL="79200" marR="79200" marT="21600" marB="21600" anchor="ctr">
@@ -6232,6 +6307,11 @@
                     </a:solidFill>
                   </a:tcPr>
                 </a:tc>
+                <a:extLst>
+                  <a:ext uri="{0D108BD9-81ED-4DB2-BD59-A6C34878D82A}">
+                    <a16:rowId xmlns:a16="http://schemas.microsoft.com/office/drawing/2014/main" val="10003"/>
+                  </a:ext>
+                </a:extLst>
               </a:tr>
               <a:tr h="558000">
                 <a:tc>
@@ -6278,6 +6358,11 @@
                     </a:solidFill>
                   </a:tcPr>
                 </a:tc>
+                <a:extLst>
+                  <a:ext uri="{0D108BD9-81ED-4DB2-BD59-A6C34878D82A}">
+                    <a16:rowId xmlns:a16="http://schemas.microsoft.com/office/drawing/2014/main" val="10004"/>
+                  </a:ext>
+                </a:extLst>
               </a:tr>
               <a:tr h="558000">
                 <a:tc>
@@ -6324,6 +6409,11 @@
                     </a:solidFill>
                   </a:tcPr>
                 </a:tc>
+                <a:extLst>
+                  <a:ext uri="{0D108BD9-81ED-4DB2-BD59-A6C34878D82A}">
+                    <a16:rowId xmlns:a16="http://schemas.microsoft.com/office/drawing/2014/main" val="10005"/>
+                  </a:ext>
+                </a:extLst>
               </a:tr>
               <a:tr h="558000">
                 <a:tc>
@@ -6370,6 +6460,11 @@
                     </a:solidFill>
                   </a:tcPr>
                 </a:tc>
+                <a:extLst>
+                  <a:ext uri="{0D108BD9-81ED-4DB2-BD59-A6C34878D82A}">
+                    <a16:rowId xmlns:a16="http://schemas.microsoft.com/office/drawing/2014/main" val="10006"/>
+                  </a:ext>
+                </a:extLst>
               </a:tr>
             </a:tbl>
           </a:graphicData>
@@ -6414,7 +6509,7 @@
           </a:fontRef>
         </p:style>
         <p:txBody>
-          <a:bodyPr rtlCol="0" anchor="ctr" wrap="square" lIns="108000" rIns="108000" tIns="54000" bIns="54000"/>
+          <a:bodyPr wrap="square" lIns="108000" tIns="54000" rIns="108000" bIns="54000" rtlCol="0" anchor="ctr"/>
           <a:lstStyle/>
           <a:p>
             <a:pPr algn="ctr">
@@ -6451,7 +6546,7 @@
           <a:noFill/>
         </p:spPr>
         <p:txBody>
-          <a:bodyPr wrap="square" anchor="t" lIns="43200" rIns="43200" tIns="43200" bIns="43200"/>
+          <a:bodyPr wrap="square" lIns="43200" tIns="43200" rIns="43200" bIns="43200" anchor="t"/>
           <a:lstStyle/>
           <a:p>
             <a:pPr algn="l">
@@ -6627,7 +6722,7 @@
           </a:fontRef>
         </p:style>
         <p:txBody>
-          <a:bodyPr rtlCol="0" anchor="ctr" wrap="square" lIns="108000" rIns="108000" tIns="54000" bIns="54000"/>
+          <a:bodyPr wrap="square" lIns="108000" tIns="54000" rIns="108000" bIns="54000" rtlCol="0" anchor="ctr"/>
           <a:lstStyle/>
           <a:p>
             <a:pPr algn="ctr">
@@ -6710,10 +6805,11 @@
           </a:fontRef>
         </p:style>
         <p:txBody>
-          <a:bodyPr rtlCol="0" anchor="ctr" wrap="square" lIns="108000" rIns="108000" tIns="54000" bIns="54000"/>
+          <a:bodyPr wrap="square" lIns="108000" tIns="54000" rIns="108000" bIns="54000" rtlCol="0" anchor="ctr"/>
           <a:lstStyle/>
           <a:p>
             <a:pPr algn="ctr"/>
+            <a:endParaRPr/>
           </a:p>
         </p:txBody>
       </p:sp>
@@ -6734,7 +6830,7 @@
           <a:noFill/>
         </p:spPr>
         <p:txBody>
-          <a:bodyPr wrap="square" anchor="t" lIns="43200" rIns="43200" tIns="43200" bIns="43200"/>
+          <a:bodyPr wrap="square" lIns="43200" tIns="43200" rIns="43200" bIns="43200" anchor="t"/>
           <a:lstStyle/>
           <a:p>
             <a:pPr algn="l">
@@ -6774,7 +6870,7 @@
           <a:noFill/>
         </p:spPr>
         <p:txBody>
-          <a:bodyPr wrap="square" anchor="t" lIns="43200" rIns="43200" tIns="43200" bIns="43200"/>
+          <a:bodyPr wrap="square" lIns="43200" tIns="43200" rIns="43200" bIns="43200" anchor="t"/>
           <a:lstStyle/>
           <a:p>
             <a:pPr algn="l">
@@ -6929,7 +7025,7 @@
           </a:fontRef>
         </p:style>
         <p:txBody>
-          <a:bodyPr rtlCol="0" anchor="ctr" wrap="square" lIns="108000" rIns="108000" tIns="54000" bIns="54000"/>
+          <a:bodyPr wrap="square" lIns="108000" tIns="54000" rIns="108000" bIns="54000" rtlCol="0" anchor="ctr"/>
           <a:lstStyle/>
           <a:p>
             <a:pPr algn="ctr">
@@ -6988,7 +7084,7 @@
           </a:fontRef>
         </p:style>
         <p:txBody>
-          <a:bodyPr rtlCol="0" anchor="ctr" wrap="square" lIns="108000" rIns="108000" tIns="54000" bIns="54000"/>
+          <a:bodyPr wrap="square" lIns="108000" tIns="54000" rIns="108000" bIns="54000" rtlCol="0" anchor="ctr"/>
           <a:lstStyle/>
           <a:p>
             <a:pPr algn="ctr">
@@ -6997,14 +7093,20 @@
               </a:lnSpc>
             </a:pPr>
             <a:r>
-              <a:rPr sz="4400" b="1">
+              <a:rPr lang="pt-BR" sz="4400" b="1">
                 <a:solidFill>
                   <a:srgbClr val="71388D"/>
                 </a:solidFill>
                 <a:latin typeface="Arial"/>
               </a:rPr>
-              <a:t>92</a:t>
-            </a:r>
+              <a:t>146</a:t>
+            </a:r>
+            <a:endParaRPr sz="4400" b="1">
+              <a:solidFill>
+                <a:srgbClr val="71388D"/>
+              </a:solidFill>
+              <a:latin typeface="Arial"/>
+            </a:endParaRPr>
           </a:p>
           <a:p>
             <a:pPr algn="ctr">
@@ -7063,7 +7165,7 @@
           </a:fontRef>
         </p:style>
         <p:txBody>
-          <a:bodyPr rtlCol="0" anchor="ctr" wrap="square" lIns="108000" rIns="108000" tIns="54000" bIns="54000"/>
+          <a:bodyPr wrap="square" lIns="108000" tIns="54000" rIns="108000" bIns="54000" rtlCol="0" anchor="ctr"/>
           <a:lstStyle/>
           <a:p>
             <a:pPr algn="ctr">
@@ -7138,7 +7240,7 @@
           </a:fontRef>
         </p:style>
         <p:txBody>
-          <a:bodyPr rtlCol="0" anchor="ctr" wrap="square" lIns="108000" rIns="108000" tIns="54000" bIns="54000"/>
+          <a:bodyPr wrap="square" lIns="108000" tIns="54000" rIns="108000" bIns="54000" rtlCol="0" anchor="ctr"/>
           <a:lstStyle/>
           <a:p>
             <a:pPr algn="ctr">
@@ -7191,7 +7293,7 @@
           <a:noFill/>
         </p:spPr>
         <p:txBody>
-          <a:bodyPr wrap="square" anchor="t" lIns="43200" rIns="43200" tIns="43200" bIns="43200"/>
+          <a:bodyPr wrap="square" lIns="43200" tIns="43200" rIns="43200" bIns="43200" anchor="t"/>
           <a:lstStyle/>
           <a:p>
             <a:pPr algn="l">
@@ -7253,7 +7355,7 @@
           </a:fontRef>
         </p:style>
         <p:txBody>
-          <a:bodyPr rtlCol="0" anchor="ctr" wrap="square" lIns="108000" rIns="108000" tIns="54000" bIns="54000"/>
+          <a:bodyPr wrap="square" lIns="108000" tIns="54000" rIns="108000" bIns="54000" rtlCol="0" anchor="ctr"/>
           <a:lstStyle/>
           <a:p>
             <a:pPr algn="ctr">
@@ -7290,7 +7392,7 @@
           <a:noFill/>
         </p:spPr>
         <p:txBody>
-          <a:bodyPr wrap="square" anchor="t" lIns="43200" rIns="43200" tIns="43200" bIns="43200"/>
+          <a:bodyPr wrap="square" lIns="43200" tIns="43200" rIns="43200" bIns="43200" anchor="t"/>
           <a:lstStyle/>
           <a:p>
             <a:pPr algn="l">

</xml_diff>

<commit_message>
adiciona rota de saúde e backup cifrado do banco, aceita o risco do MaterialSalvo e atualiza a documentação
</commit_message>
<xml_diff>
--- a/docs/poster/Poster_Health_In_Sight.pptx
+++ b/docs/poster/Poster_Health_In_Sight.pptx
@@ -3718,7 +3718,7 @@
                 </a:solidFill>
                 <a:latin typeface="Arial"/>
               </a:rPr>
-              <a:t>146 testes automatizados</a:t>
+              <a:t>162 testes automatizados</a:t>
             </a:r>
             <a:r>
               <a:rPr sz="2200" b="0">
@@ -7099,7 +7099,7 @@
                 </a:solidFill>
                 <a:latin typeface="Arial"/>
               </a:rPr>
-              <a:t>146</a:t>
+              <a:t>162</a:t>
             </a:r>
             <a:endParaRPr sz="4400" b="1">
               <a:solidFill>

</xml_diff>